<commit_message>
Update slide deck to latest version
Co-authored-by: Cursor <cursoragent@cursor.com>
</commit_message>
<xml_diff>
--- a/kyverno-demo.pptx
+++ b/kyverno-demo.pptx
@@ -151,6 +151,7 @@
 <p1510:revInfo xmlns:a="http://schemas.openxmlformats.org/drawingml/2006/main" xmlns:r="http://schemas.openxmlformats.org/officeDocument/2006/relationships" xmlns:p1510="http://schemas.microsoft.com/office/powerpoint/2015/10/main">
   <p1510:revLst>
     <p1510:client id="{5C7A7C19-17A7-2556-668E-9128A0750CC5}" v="65" dt="2026-10-29T15:29:00.119"/>
+    <p1510:client id="{E14687BD-7748-D53A-2EAA-443C3BB2FFDA}" v="18" dt="2026-10-29T15:48:11.650"/>
   </p1510:revLst>
 </p1510:revInfo>
 </file>
@@ -5364,7 +5365,7 @@
         <p:spPr>
           <a:xfrm>
             <a:off x="7763256" y="4315968"/>
-            <a:ext cx="3895344" cy="685800"/>
+            <a:ext cx="3895344" cy="725711"/>
           </a:xfrm>
           <a:prstGeom prst="rect">
             <a:avLst/>
@@ -5377,11 +5378,19 @@
           </a:bodyPr>
           <a:lstStyle/>
           <a:p>
-            <a:pPr algn="l">
+            <a:pPr>
               <a:lnSpc>
                 <a:spcPct val="115000"/>
               </a:lnSpc>
             </a:pPr>
+            <a:br>
+              <a:rPr lang="en-US" sz="1400" dirty="0">
+                <a:solidFill>
+                  <a:srgbClr val="1A1B1F"/>
+                </a:solidFill>
+                <a:latin typeface="Montserrat"/>
+              </a:rPr>
+            </a:br>
             <a:r>
               <a:rPr sz="1400" b="0" i="0">
                 <a:solidFill>
@@ -8949,53 +8958,6 @@
       </p:sp>
       <p:sp>
         <p:nvSpPr>
-          <p:cNvPr id="3" name="Rounded Rectangle 2"/>
-          <p:cNvSpPr/>
-          <p:nvPr/>
-        </p:nvSpPr>
-        <p:spPr>
-          <a:xfrm rot="1080000">
-            <a:off x="10911535" y="-457200"/>
-            <a:ext cx="1737360" cy="1737360"/>
-          </a:xfrm>
-          <a:prstGeom prst="roundRect">
-            <a:avLst>
-              <a:gd name="adj" fmla="val 22000"/>
-            </a:avLst>
-          </a:prstGeom>
-          <a:solidFill>
-            <a:srgbClr val="EF4023"/>
-          </a:solidFill>
-          <a:ln>
-            <a:noFill/>
-          </a:ln>
-          <a:effectLst/>
-        </p:spPr>
-        <p:style>
-          <a:lnRef idx="1">
-            <a:schemeClr val="accent1"/>
-          </a:lnRef>
-          <a:fillRef idx="3">
-            <a:schemeClr val="accent1"/>
-          </a:fillRef>
-          <a:effectRef idx="2">
-            <a:schemeClr val="accent1"/>
-          </a:effectRef>
-          <a:fontRef idx="minor">
-            <a:schemeClr val="lt1"/>
-          </a:fontRef>
-        </p:style>
-        <p:txBody>
-          <a:bodyPr rtlCol="0" anchor="ctr"/>
-          <a:lstStyle/>
-          <a:p>
-            <a:pPr algn="ctr"/>
-            <a:endParaRPr/>
-          </a:p>
-        </p:txBody>
-      </p:sp>
-      <p:sp>
-        <p:nvSpPr>
           <p:cNvPr id="4" name="Rounded Rectangle 3"/>
           <p:cNvSpPr/>
           <p:nvPr/>
@@ -17056,53 +17018,6 @@
           </a:p>
         </p:txBody>
       </p:sp>
-      <p:sp>
-        <p:nvSpPr>
-          <p:cNvPr id="3" name="Rounded Rectangle 2"/>
-          <p:cNvSpPr/>
-          <p:nvPr/>
-        </p:nvSpPr>
-        <p:spPr>
-          <a:xfrm rot="1080000">
-            <a:off x="10271455" y="-457200"/>
-            <a:ext cx="2377440" cy="2377440"/>
-          </a:xfrm>
-          <a:prstGeom prst="roundRect">
-            <a:avLst>
-              <a:gd name="adj" fmla="val 22000"/>
-            </a:avLst>
-          </a:prstGeom>
-          <a:solidFill>
-            <a:srgbClr val="EF4023"/>
-          </a:solidFill>
-          <a:ln>
-            <a:noFill/>
-          </a:ln>
-          <a:effectLst/>
-        </p:spPr>
-        <p:style>
-          <a:lnRef idx="1">
-            <a:schemeClr val="accent1"/>
-          </a:lnRef>
-          <a:fillRef idx="3">
-            <a:schemeClr val="accent1"/>
-          </a:fillRef>
-          <a:effectRef idx="2">
-            <a:schemeClr val="accent1"/>
-          </a:effectRef>
-          <a:fontRef idx="minor">
-            <a:schemeClr val="lt1"/>
-          </a:fontRef>
-        </p:style>
-        <p:txBody>
-          <a:bodyPr rtlCol="0" anchor="ctr"/>
-          <a:lstStyle/>
-          <a:p>
-            <a:pPr algn="ctr"/>
-            <a:endParaRPr/>
-          </a:p>
-        </p:txBody>
-      </p:sp>
       <p:pic>
         <p:nvPicPr>
           <p:cNvPr id="4" name="Picture 3" descr="mitesp-mark.png"/>
@@ -17135,8 +17050,8 @@
         </p:nvSpPr>
         <p:spPr>
           <a:xfrm>
-            <a:off x="1143000" y="457200"/>
-            <a:ext cx="3657600" cy="457200"/>
+            <a:off x="1143000" y="570384"/>
+            <a:ext cx="3657600" cy="230832"/>
           </a:xfrm>
           <a:prstGeom prst="rect">
             <a:avLst/>
@@ -17149,19 +17064,32 @@
           </a:bodyPr>
           <a:lstStyle/>
           <a:p>
-            <a:pPr algn="l">
-              <a:lnSpc>
-                <a:spcPct val="100000"/>
-              </a:lnSpc>
-            </a:pPr>
-            <a:r>
-              <a:rPr sz="1500" b="1" i="0">
+            <a:r>
+              <a:rPr lang="en-US" sz="1500" b="1" dirty="0">
                 <a:solidFill>
                   <a:srgbClr val="FFFFFF"/>
                 </a:solidFill>
                 <a:latin typeface="Montserrat"/>
               </a:rPr>
-              <a:t>MillenniumIT ESP</a:t>
+              <a:t>          </a:t>
+            </a:r>
+            <a:r>
+              <a:rPr sz="1500" b="1" i="0" dirty="0" err="1">
+                <a:solidFill>
+                  <a:srgbClr val="FFFFFF"/>
+                </a:solidFill>
+                <a:latin typeface="Montserrat"/>
+              </a:rPr>
+              <a:t>MillenniumIT</a:t>
+            </a:r>
+            <a:r>
+              <a:rPr sz="1500" b="1" i="0" dirty="0">
+                <a:solidFill>
+                  <a:srgbClr val="FFFFFF"/>
+                </a:solidFill>
+                <a:latin typeface="Montserrat"/>
+              </a:rPr>
+              <a:t> ESP</a:t>
             </a:r>
           </a:p>
         </p:txBody>
@@ -19940,53 +19868,6 @@
           </a:prstGeom>
           <a:solidFill>
             <a:srgbClr val="14171A"/>
-          </a:solidFill>
-          <a:ln>
-            <a:noFill/>
-          </a:ln>
-          <a:effectLst/>
-        </p:spPr>
-        <p:style>
-          <a:lnRef idx="1">
-            <a:schemeClr val="accent1"/>
-          </a:lnRef>
-          <a:fillRef idx="3">
-            <a:schemeClr val="accent1"/>
-          </a:fillRef>
-          <a:effectRef idx="2">
-            <a:schemeClr val="accent1"/>
-          </a:effectRef>
-          <a:fontRef idx="minor">
-            <a:schemeClr val="lt1"/>
-          </a:fontRef>
-        </p:style>
-        <p:txBody>
-          <a:bodyPr rtlCol="0" anchor="ctr"/>
-          <a:lstStyle/>
-          <a:p>
-            <a:pPr algn="ctr"/>
-            <a:endParaRPr/>
-          </a:p>
-        </p:txBody>
-      </p:sp>
-      <p:sp>
-        <p:nvSpPr>
-          <p:cNvPr id="3" name="Rounded Rectangle 2"/>
-          <p:cNvSpPr/>
-          <p:nvPr/>
-        </p:nvSpPr>
-        <p:spPr>
-          <a:xfrm rot="1080000">
-            <a:off x="10911535" y="-457200"/>
-            <a:ext cx="1737360" cy="1737360"/>
-          </a:xfrm>
-          <a:prstGeom prst="roundRect">
-            <a:avLst>
-              <a:gd name="adj" fmla="val 22000"/>
-            </a:avLst>
-          </a:prstGeom>
-          <a:solidFill>
-            <a:srgbClr val="EF4023"/>
           </a:solidFill>
           <a:ln>
             <a:noFill/>

</xml_diff>